<commit_message>
docs: line-by-line audit against code — 31 corrections
Co-Authored-By: Claude Fable 5 <noreply@anthropic.com>
</commit_message>
<xml_diff>
--- a/docs/gallery/demo-deck.pptx
+++ b/docs/gallery/demo-deck.pptx
@@ -3252,7 +3252,7 @@
                 </a:solidFill>
                 <a:latin typeface="Helvetica Neue"/>
               </a:rPr>
-              <a:t>Session 'gallery' · 28 evidence items · 9 options · register 4/2/4 (supported/contradicted/untested) · ~$10.23</a:t>
+              <a:t>Session 'gallery' · 28 evidence items · 9 options · register 4/2/4 (supported/contradicted/untested) · ~$10.36</a:t>
             </a:r>
           </a:p>
         </p:txBody>
@@ -4512,7 +4512,7 @@
                           </a:solidFill>
                           <a:latin typeface="Helvetica Neue"/>
                         </a:rPr>
-                        <a:t>$10.23 · 62 model calls</a:t>
+                        <a:t>$10.36 · 63 model calls</a:t>
                       </a:r>
                     </a:p>
                   </a:txBody>
@@ -5538,7 +5538,7 @@
                 </a:solidFill>
                 <a:latin typeface="Helvetica Neue"/>
               </a:rPr>
-              <a:t>•  claude-opus-5: 11 calls, $2.03</a:t>
+              <a:t>•  claude-opus-5: 12 calls, $2.16</a:t>
             </a:r>
           </a:p>
           <a:p>
@@ -7371,7 +7371,7 @@
                 </a:solidFill>
                 <a:latin typeface="Helvetica Neue"/>
               </a:rPr>
-              <a:t>•  feasibility: red verdict on 9833796ca27440a4a50a86f45c4fb983: verdict red, effort L - A rider-voted pickup map fights the optimizer head-on; every vote becomes a c</a:t>
+              <a:t>•  feasibility: red verdict on 4e51e915d49843be82430d6bb9293a77: verdict red, effort L - A rider-voted pickup map fights the optimizer head-on; every vote becomes a c</a:t>
             </a:r>
           </a:p>
         </p:txBody>
@@ -9044,7 +9044,7 @@
                 </a:solidFill>
                 <a:latin typeface="Helvetica Neue"/>
               </a:rPr>
-              <a:t>Kata interventions (7)</a:t>
+              <a:t>Kata interventions (8)</a:t>
             </a:r>
           </a:p>
           <a:p>
@@ -9124,7 +9124,7 @@
                 </a:solidFill>
                 <a:latin typeface="Helvetica Neue"/>
               </a:rPr>
-              <a:t>•  stage_contract (prototype)</a:t>
+              <a:t>•  timebox_pivot (ideate)</a:t>
             </a:r>
           </a:p>
         </p:txBody>

</xml_diff>

<commit_message>
Docs line-by-line audit (31 corrections) + restored MCP budget guardrail (#66)
* docs: line-by-line audit against code — 31 corrections

Co-Authored-By: Claude Fable 5 <noreply@anthropic.com>

* fix(mcp): restore the 20M default budget guardrail dropped from #63; docs audit follow-ups

The #63 batch script aborted on an assertion before this fix ran, while the
commit message still claimed it - caught by the line-by-line docs audit
('docs follow code' surfaced the missing code). Now with a test pinning the
journaled default, and docs/mcp.md describes the real behavior.

Co-Authored-By: Claude Fable 5 <noreply@anthropic.com>

---------

Co-authored-by: Claude Fable 5 <noreply@anthropic.com>
</commit_message>
<xml_diff>
--- a/docs/gallery/demo-deck.pptx
+++ b/docs/gallery/demo-deck.pptx
@@ -3252,7 +3252,7 @@
                 </a:solidFill>
                 <a:latin typeface="Helvetica Neue"/>
               </a:rPr>
-              <a:t>Session 'gallery' · 28 evidence items · 9 options · register 4/2/4 (supported/contradicted/untested) · ~$10.23</a:t>
+              <a:t>Session 'gallery' · 28 evidence items · 9 options · register 4/2/4 (supported/contradicted/untested) · ~$10.36</a:t>
             </a:r>
           </a:p>
         </p:txBody>
@@ -4512,7 +4512,7 @@
                           </a:solidFill>
                           <a:latin typeface="Helvetica Neue"/>
                         </a:rPr>
-                        <a:t>$10.23 · 62 model calls</a:t>
+                        <a:t>$10.36 · 63 model calls</a:t>
                       </a:r>
                     </a:p>
                   </a:txBody>
@@ -5538,7 +5538,7 @@
                 </a:solidFill>
                 <a:latin typeface="Helvetica Neue"/>
               </a:rPr>
-              <a:t>•  claude-opus-5: 11 calls, $2.03</a:t>
+              <a:t>•  claude-opus-5: 12 calls, $2.16</a:t>
             </a:r>
           </a:p>
           <a:p>
@@ -7371,7 +7371,7 @@
                 </a:solidFill>
                 <a:latin typeface="Helvetica Neue"/>
               </a:rPr>
-              <a:t>•  feasibility: red verdict on 9833796ca27440a4a50a86f45c4fb983: verdict red, effort L - A rider-voted pickup map fights the optimizer head-on; every vote becomes a c</a:t>
+              <a:t>•  feasibility: red verdict on 4e51e915d49843be82430d6bb9293a77: verdict red, effort L - A rider-voted pickup map fights the optimizer head-on; every vote becomes a c</a:t>
             </a:r>
           </a:p>
         </p:txBody>
@@ -9044,7 +9044,7 @@
                 </a:solidFill>
                 <a:latin typeface="Helvetica Neue"/>
               </a:rPr>
-              <a:t>Kata interventions (7)</a:t>
+              <a:t>Kata interventions (8)</a:t>
             </a:r>
           </a:p>
           <a:p>
@@ -9124,7 +9124,7 @@
                 </a:solidFill>
                 <a:latin typeface="Helvetica Neue"/>
               </a:rPr>
-              <a:t>•  stage_contract (prototype)</a:t>
+              <a:t>•  timebox_pivot (ideate)</a:t>
             </a:r>
           </a:p>
         </p:txBody>

</xml_diff>